<commit_message>
subida imagen faltante del manual de instrucciones
</commit_message>
<xml_diff>
--- a/media/Instrucciones de uso/Imágenes - Instrucciones de uso.pptx
+++ b/media/Instrucciones de uso/Imágenes - Instrucciones de uso.pptx
@@ -12,6 +12,7 @@
     <p:sldId id="262" r:id="rId6"/>
     <p:sldId id="261" r:id="rId7"/>
     <p:sldId id="258" r:id="rId8"/>
+    <p:sldId id="263" r:id="rId9"/>
   </p:sldIdLst>
   <p:sldSz cx="12192000" cy="6858000"/>
   <p:notesSz cx="6858000" cy="9144000"/>
@@ -267,7 +268,7 @@
           <a:p>
             <a:fld id="{649C810B-99D0-4413-9CAF-3E5DB0B2790C}" type="datetimeFigureOut">
               <a:rPr lang="es-MX" smtClean="0"/>
-              <a:t>13/09/2026</a:t>
+              <a:t>15/09/2026</a:t>
             </a:fld>
             <a:endParaRPr lang="es-MX"/>
           </a:p>
@@ -467,7 +468,7 @@
           <a:p>
             <a:fld id="{649C810B-99D0-4413-9CAF-3E5DB0B2790C}" type="datetimeFigureOut">
               <a:rPr lang="es-MX" smtClean="0"/>
-              <a:t>13/09/2026</a:t>
+              <a:t>15/09/2026</a:t>
             </a:fld>
             <a:endParaRPr lang="es-MX"/>
           </a:p>
@@ -677,7 +678,7 @@
           <a:p>
             <a:fld id="{649C810B-99D0-4413-9CAF-3E5DB0B2790C}" type="datetimeFigureOut">
               <a:rPr lang="es-MX" smtClean="0"/>
-              <a:t>13/09/2026</a:t>
+              <a:t>15/09/2026</a:t>
             </a:fld>
             <a:endParaRPr lang="es-MX"/>
           </a:p>
@@ -877,7 +878,7 @@
           <a:p>
             <a:fld id="{649C810B-99D0-4413-9CAF-3E5DB0B2790C}" type="datetimeFigureOut">
               <a:rPr lang="es-MX" smtClean="0"/>
-              <a:t>13/09/2026</a:t>
+              <a:t>15/09/2026</a:t>
             </a:fld>
             <a:endParaRPr lang="es-MX"/>
           </a:p>
@@ -1153,7 +1154,7 @@
           <a:p>
             <a:fld id="{649C810B-99D0-4413-9CAF-3E5DB0B2790C}" type="datetimeFigureOut">
               <a:rPr lang="es-MX" smtClean="0"/>
-              <a:t>13/09/2026</a:t>
+              <a:t>15/09/2026</a:t>
             </a:fld>
             <a:endParaRPr lang="es-MX"/>
           </a:p>
@@ -1421,7 +1422,7 @@
           <a:p>
             <a:fld id="{649C810B-99D0-4413-9CAF-3E5DB0B2790C}" type="datetimeFigureOut">
               <a:rPr lang="es-MX" smtClean="0"/>
-              <a:t>13/09/2026</a:t>
+              <a:t>15/09/2026</a:t>
             </a:fld>
             <a:endParaRPr lang="es-MX"/>
           </a:p>
@@ -1836,7 +1837,7 @@
           <a:p>
             <a:fld id="{649C810B-99D0-4413-9CAF-3E5DB0B2790C}" type="datetimeFigureOut">
               <a:rPr lang="es-MX" smtClean="0"/>
-              <a:t>13/09/2026</a:t>
+              <a:t>15/09/2026</a:t>
             </a:fld>
             <a:endParaRPr lang="es-MX"/>
           </a:p>
@@ -1978,7 +1979,7 @@
           <a:p>
             <a:fld id="{649C810B-99D0-4413-9CAF-3E5DB0B2790C}" type="datetimeFigureOut">
               <a:rPr lang="es-MX" smtClean="0"/>
-              <a:t>13/09/2026</a:t>
+              <a:t>15/09/2026</a:t>
             </a:fld>
             <a:endParaRPr lang="es-MX"/>
           </a:p>
@@ -2091,7 +2092,7 @@
           <a:p>
             <a:fld id="{649C810B-99D0-4413-9CAF-3E5DB0B2790C}" type="datetimeFigureOut">
               <a:rPr lang="es-MX" smtClean="0"/>
-              <a:t>13/09/2026</a:t>
+              <a:t>15/09/2026</a:t>
             </a:fld>
             <a:endParaRPr lang="es-MX"/>
           </a:p>
@@ -2404,7 +2405,7 @@
           <a:p>
             <a:fld id="{649C810B-99D0-4413-9CAF-3E5DB0B2790C}" type="datetimeFigureOut">
               <a:rPr lang="es-MX" smtClean="0"/>
-              <a:t>13/09/2026</a:t>
+              <a:t>15/09/2026</a:t>
             </a:fld>
             <a:endParaRPr lang="es-MX"/>
           </a:p>
@@ -2693,7 +2694,7 @@
           <a:p>
             <a:fld id="{649C810B-99D0-4413-9CAF-3E5DB0B2790C}" type="datetimeFigureOut">
               <a:rPr lang="es-MX" smtClean="0"/>
-              <a:t>13/09/2026</a:t>
+              <a:t>15/09/2026</a:t>
             </a:fld>
             <a:endParaRPr lang="es-MX"/>
           </a:p>
@@ -2936,7 +2937,7 @@
           <a:p>
             <a:fld id="{649C810B-99D0-4413-9CAF-3E5DB0B2790C}" type="datetimeFigureOut">
               <a:rPr lang="es-MX" smtClean="0"/>
-              <a:t>13/09/2026</a:t>
+              <a:t>15/09/2026</a:t>
             </a:fld>
             <a:endParaRPr lang="es-MX"/>
           </a:p>
@@ -5865,6 +5866,253 @@
 </p:sld>
 </file>
 
+<file path=ppt/slides/slide8.xml><?xml version="1.0" encoding="utf-8"?>
+<p:sld xmlns:a="http://schemas.openxmlformats.org/drawingml/2006/main" xmlns:r="http://schemas.openxmlformats.org/officeDocument/2006/relationships" xmlns:p="http://schemas.openxmlformats.org/presentationml/2006/main">
+  <p:cSld>
+    <p:spTree>
+      <p:nvGrpSpPr>
+        <p:cNvPr id="1" name=""/>
+        <p:cNvGrpSpPr/>
+        <p:nvPr/>
+      </p:nvGrpSpPr>
+      <p:grpSpPr>
+        <a:xfrm>
+          <a:off x="0" y="0"/>
+          <a:ext cx="0" cy="0"/>
+          <a:chOff x="0" y="0"/>
+          <a:chExt cx="0" cy="0"/>
+        </a:xfrm>
+      </p:grpSpPr>
+      <p:grpSp>
+        <p:nvGrpSpPr>
+          <p:cNvPr id="14" name="Group 13">
+            <a:extLst>
+              <a:ext uri="{FF2B5EF4-FFF2-40B4-BE49-F238E27FC236}">
+                <a16:creationId xmlns:a16="http://schemas.microsoft.com/office/drawing/2014/main" id="{0026AD0B-00F9-1848-10BA-39FC5FD15D89}"/>
+              </a:ext>
+            </a:extLst>
+          </p:cNvPr>
+          <p:cNvGrpSpPr/>
+          <p:nvPr/>
+        </p:nvGrpSpPr>
+        <p:grpSpPr>
+          <a:xfrm>
+            <a:off x="3374507" y="0"/>
+            <a:ext cx="5442985" cy="6858000"/>
+            <a:chOff x="3374507" y="0"/>
+            <a:chExt cx="5442985" cy="6858000"/>
+          </a:xfrm>
+        </p:grpSpPr>
+        <p:pic>
+          <p:nvPicPr>
+            <p:cNvPr id="5" name="Picture 4">
+              <a:extLst>
+                <a:ext uri="{FF2B5EF4-FFF2-40B4-BE49-F238E27FC236}">
+                  <a16:creationId xmlns:a16="http://schemas.microsoft.com/office/drawing/2014/main" id="{9664CA4F-E182-4540-4731-C4889C979E7C}"/>
+                </a:ext>
+              </a:extLst>
+            </p:cNvPr>
+            <p:cNvPicPr>
+              <a:picLocks noChangeAspect="1"/>
+            </p:cNvPicPr>
+            <p:nvPr/>
+          </p:nvPicPr>
+          <p:blipFill>
+            <a:blip r:embed="rId2">
+              <a:extLst>
+                <a:ext uri="{28A0092B-C50C-407E-A947-70E740481C1C}">
+                  <a14:useLocalDpi xmlns:a14="http://schemas.microsoft.com/office/drawing/2010/main" val="0"/>
+                </a:ext>
+              </a:extLst>
+            </a:blip>
+            <a:stretch>
+              <a:fillRect/>
+            </a:stretch>
+          </p:blipFill>
+          <p:spPr>
+            <a:xfrm>
+              <a:off x="3374507" y="0"/>
+              <a:ext cx="5442985" cy="6858000"/>
+            </a:xfrm>
+            <a:prstGeom prst="rect">
+              <a:avLst/>
+            </a:prstGeom>
+          </p:spPr>
+        </p:pic>
+        <p:sp>
+          <p:nvSpPr>
+            <p:cNvPr id="7" name="TextBox 6">
+              <a:extLst>
+                <a:ext uri="{FF2B5EF4-FFF2-40B4-BE49-F238E27FC236}">
+                  <a16:creationId xmlns:a16="http://schemas.microsoft.com/office/drawing/2014/main" id="{B79DEEDF-570F-06E6-F4DF-1707DFBEAA1D}"/>
+                </a:ext>
+              </a:extLst>
+            </p:cNvPr>
+            <p:cNvSpPr txBox="1"/>
+            <p:nvPr/>
+          </p:nvSpPr>
+          <p:spPr>
+            <a:xfrm>
+              <a:off x="6800742" y="5133717"/>
+              <a:ext cx="1558375" cy="369332"/>
+            </a:xfrm>
+            <a:prstGeom prst="rect">
+              <a:avLst/>
+            </a:prstGeom>
+            <a:noFill/>
+          </p:spPr>
+          <p:txBody>
+            <a:bodyPr wrap="none" rtlCol="0">
+              <a:spAutoFit/>
+            </a:bodyPr>
+            <a:lstStyle/>
+            <a:p>
+              <a:r>
+                <a:rPr lang="en-GB" b="1" dirty="0"/>
+                <a:t>Entrada </a:t>
+              </a:r>
+              <a:r>
+                <a:rPr lang="en-GB" b="1" i="1" dirty="0"/>
+                <a:t>Vcc</a:t>
+              </a:r>
+              <a:r>
+                <a:rPr lang="en-GB" b="1" dirty="0"/>
+                <a:t> -</a:t>
+              </a:r>
+              <a:endParaRPr lang="es-MX" b="1" i="1" dirty="0"/>
+            </a:p>
+          </p:txBody>
+        </p:sp>
+        <p:sp>
+          <p:nvSpPr>
+            <p:cNvPr id="9" name="TextBox 8">
+              <a:extLst>
+                <a:ext uri="{FF2B5EF4-FFF2-40B4-BE49-F238E27FC236}">
+                  <a16:creationId xmlns:a16="http://schemas.microsoft.com/office/drawing/2014/main" id="{30E3D101-EE33-EF28-9D5B-AE6183AD29B2}"/>
+                </a:ext>
+              </a:extLst>
+            </p:cNvPr>
+            <p:cNvSpPr txBox="1"/>
+            <p:nvPr/>
+          </p:nvSpPr>
+          <p:spPr>
+            <a:xfrm>
+              <a:off x="6800742" y="6218624"/>
+              <a:ext cx="1603259" cy="369332"/>
+            </a:xfrm>
+            <a:prstGeom prst="rect">
+              <a:avLst/>
+            </a:prstGeom>
+            <a:noFill/>
+          </p:spPr>
+          <p:txBody>
+            <a:bodyPr wrap="none" rtlCol="0">
+              <a:spAutoFit/>
+            </a:bodyPr>
+            <a:lstStyle/>
+            <a:p>
+              <a:r>
+                <a:rPr lang="en-GB" b="1" dirty="0"/>
+                <a:t>Entrada </a:t>
+              </a:r>
+              <a:r>
+                <a:rPr lang="en-GB" b="1" i="1" dirty="0"/>
+                <a:t>Vcc</a:t>
+              </a:r>
+              <a:r>
+                <a:rPr lang="en-GB" b="1" dirty="0"/>
+                <a:t> +</a:t>
+              </a:r>
+              <a:endParaRPr lang="es-MX" b="1" i="1" dirty="0"/>
+            </a:p>
+          </p:txBody>
+        </p:sp>
+        <p:sp>
+          <p:nvSpPr>
+            <p:cNvPr id="11" name="TextBox 10">
+              <a:extLst>
+                <a:ext uri="{FF2B5EF4-FFF2-40B4-BE49-F238E27FC236}">
+                  <a16:creationId xmlns:a16="http://schemas.microsoft.com/office/drawing/2014/main" id="{EB962D8D-A3C7-4A99-28AE-518C7BCD5C3D}"/>
+                </a:ext>
+              </a:extLst>
+            </p:cNvPr>
+            <p:cNvSpPr txBox="1"/>
+            <p:nvPr/>
+          </p:nvSpPr>
+          <p:spPr>
+            <a:xfrm>
+              <a:off x="6800741" y="605475"/>
+              <a:ext cx="966931" cy="369332"/>
+            </a:xfrm>
+            <a:prstGeom prst="rect">
+              <a:avLst/>
+            </a:prstGeom>
+            <a:noFill/>
+          </p:spPr>
+          <p:txBody>
+            <a:bodyPr wrap="none" rtlCol="0">
+              <a:spAutoFit/>
+            </a:bodyPr>
+            <a:lstStyle/>
+            <a:p>
+              <a:r>
+                <a:rPr lang="en-GB" b="1" dirty="0"/>
+                <a:t>Salida -</a:t>
+              </a:r>
+              <a:endParaRPr lang="es-MX" b="1" i="1" dirty="0"/>
+            </a:p>
+          </p:txBody>
+        </p:sp>
+        <p:sp>
+          <p:nvSpPr>
+            <p:cNvPr id="13" name="TextBox 12">
+              <a:extLst>
+                <a:ext uri="{FF2B5EF4-FFF2-40B4-BE49-F238E27FC236}">
+                  <a16:creationId xmlns:a16="http://schemas.microsoft.com/office/drawing/2014/main" id="{74E6F690-25B0-A792-45E8-CE76B96DFE2F}"/>
+                </a:ext>
+              </a:extLst>
+            </p:cNvPr>
+            <p:cNvSpPr txBox="1"/>
+            <p:nvPr/>
+          </p:nvSpPr>
+          <p:spPr>
+            <a:xfrm>
+              <a:off x="6800741" y="1724283"/>
+              <a:ext cx="1011815" cy="369332"/>
+            </a:xfrm>
+            <a:prstGeom prst="rect">
+              <a:avLst/>
+            </a:prstGeom>
+            <a:noFill/>
+          </p:spPr>
+          <p:txBody>
+            <a:bodyPr wrap="none" rtlCol="0">
+              <a:spAutoFit/>
+            </a:bodyPr>
+            <a:lstStyle/>
+            <a:p>
+              <a:r>
+                <a:rPr lang="en-GB" b="1" dirty="0"/>
+                <a:t>Salida +</a:t>
+              </a:r>
+              <a:endParaRPr lang="es-MX" b="1" i="1" dirty="0"/>
+            </a:p>
+          </p:txBody>
+        </p:sp>
+      </p:grpSp>
+    </p:spTree>
+    <p:extLst>
+      <p:ext uri="{BB962C8B-B14F-4D97-AF65-F5344CB8AC3E}">
+        <p14:creationId xmlns:p14="http://schemas.microsoft.com/office/powerpoint/2010/main" val="3725272444"/>
+      </p:ext>
+    </p:extLst>
+  </p:cSld>
+  <p:clrMapOvr>
+    <a:masterClrMapping/>
+  </p:clrMapOvr>
+</p:sld>
+</file>
+
 <file path=ppt/theme/theme1.xml><?xml version="1.0" encoding="utf-8"?>
 <a:theme xmlns:a="http://schemas.openxmlformats.org/drawingml/2006/main" name="Office Theme">
   <a:themeElements>

</xml_diff>